<commit_message>
feat: v9.2 adds real Copilot interface screenshots across courseware
Add 10 screenshot slides with numbered explanations (deck now 232
slides): Excel chat pane, + grounding menu, model picker and
edit/plan/chat modes, Outlook Work/Web, Personalization, OneDrive
skills folder, Custom skills, Manage plugins & skills, the @ Skill
picker and All Agents. The same screens appear in the Learner Guide,
the lab README Screen Guides (Labs 1, 2, 3, 5, 6, 11) and the Lesson
Plan demonstrations. Lumina HR scenario, labs and timing unchanged.

Co-Authored-By: Claude Opus 5.5 <noreply@anthropic.com>
</commit_message>
<xml_diff>
--- a/labs/lab-01-excel-to-word/data/templates/Lumina_HR_Deck_Template.pptx
+++ b/labs/lab-01-excel-to-word/data/templates/Lumina_HR_Deck_Template.pptx
@@ -4097,7 +4097,7 @@
               <a:defRPr sz="1000"/>
             </a:pPr>
             <a:r>
-              <a:t>TGS-2024043856 v9.1 | Synthetic Lumina example | 2026-09-30 | All filters All | Slide1</a:t>
+              <a:t>TGS-2024043856 v9.2 | Synthetic Lumina example | 2026-09-30 | All filters All | Slide1</a:t>
             </a:r>
           </a:p>
         </p:txBody>
@@ -4212,7 +4212,7 @@
               <a:defRPr sz="1000"/>
             </a:pPr>
             <a:r>
-              <a:t>TGS-2024043856 v9.1 | Synthetic Lumina example | 2026-09-30 | All filters All | Slide2</a:t>
+              <a:t>TGS-2024043856 v9.2 | Synthetic Lumina example | 2026-09-30 | All filters All | Slide2</a:t>
             </a:r>
           </a:p>
         </p:txBody>
@@ -4327,7 +4327,7 @@
               <a:defRPr sz="1000"/>
             </a:pPr>
             <a:r>
-              <a:t>TGS-2024043856 v9.1 | Synthetic Lumina example | 2026-09-30 | All filters All | Slide3</a:t>
+              <a:t>TGS-2024043856 v9.2 | Synthetic Lumina example | 2026-09-30 | All filters All | Slide3</a:t>
             </a:r>
           </a:p>
         </p:txBody>
@@ -4442,7 +4442,7 @@
               <a:defRPr sz="1000"/>
             </a:pPr>
             <a:r>
-              <a:t>TGS-2024043856 v9.1 | Synthetic Lumina example | 2026-09-30 | All filters All | Slide4</a:t>
+              <a:t>TGS-2024043856 v9.2 | Synthetic Lumina example | 2026-09-30 | All filters All | Slide4</a:t>
             </a:r>
           </a:p>
         </p:txBody>
@@ -4557,7 +4557,7 @@
               <a:defRPr sz="1000"/>
             </a:pPr>
             <a:r>
-              <a:t>TGS-2024043856 v9.1 | Synthetic Lumina example | 2026-09-30 | All filters All | Slide5</a:t>
+              <a:t>TGS-2024043856 v9.2 | Synthetic Lumina example | 2026-09-30 | All filters All | Slide5</a:t>
             </a:r>
           </a:p>
         </p:txBody>
@@ -4672,7 +4672,7 @@
               <a:defRPr sz="1000"/>
             </a:pPr>
             <a:r>
-              <a:t>TGS-2024043856 v9.1 | Synthetic Lumina example | 2026-09-30 | All filters All | Slide6</a:t>
+              <a:t>TGS-2024043856 v9.2 | Synthetic Lumina example | 2026-09-30 | All filters All | Slide6</a:t>
             </a:r>
           </a:p>
         </p:txBody>
@@ -4787,7 +4787,7 @@
               <a:defRPr sz="1000"/>
             </a:pPr>
             <a:r>
-              <a:t>TGS-2024043856 v9.1 | Synthetic Lumina example | 2026-09-30 | All filters All | Slide7</a:t>
+              <a:t>TGS-2024043856 v9.2 | Synthetic Lumina example | 2026-09-30 | All filters All | Slide7</a:t>
             </a:r>
           </a:p>
         </p:txBody>
@@ -4902,7 +4902,7 @@
               <a:defRPr sz="1000"/>
             </a:pPr>
             <a:r>
-              <a:t>TGS-2024043856 v9.1 | Synthetic Lumina example | 2026-09-30 | All filters All | Slide8</a:t>
+              <a:t>TGS-2024043856 v9.2 | Synthetic Lumina example | 2026-09-30 | All filters All | Slide8</a:t>
             </a:r>
           </a:p>
         </p:txBody>

</xml_diff>

<commit_message>
feat: v9.3 removes Microsoft Loop and adds dashboard and Pareto visuals
LO4 now reads "Design a training plan for staff to use Microsoft
Copilot Studio"; Lab 14 tracks staff practice in an Excel staff
enablement tracker instead of Loop. Add worked Lumina HR slides for
"What Is a Pareto Chart?", "What Is an Interactive Dashboard?" and
an All vs Retail Sales filter comparison, rendered from real formula
workbooks; the same visuals are in the Learner Guide and labs.

Co-Authored-By: Claude Opus 5.5 <noreply@anthropic.com>
</commit_message>
<xml_diff>
--- a/labs/lab-01-excel-to-word/data/templates/Lumina_HR_Deck_Template.pptx
+++ b/labs/lab-01-excel-to-word/data/templates/Lumina_HR_Deck_Template.pptx
@@ -4097,7 +4097,7 @@
               <a:defRPr sz="1000"/>
             </a:pPr>
             <a:r>
-              <a:t>TGS-2024043856 v9.2 | Synthetic Lumina example | 2026-09-30 | All filters All | Slide1</a:t>
+              <a:t>TGS-2024043856 v9.3 | Synthetic Lumina example | 2026-09-30 | All filters All | Slide1</a:t>
             </a:r>
           </a:p>
         </p:txBody>
@@ -4212,7 +4212,7 @@
               <a:defRPr sz="1000"/>
             </a:pPr>
             <a:r>
-              <a:t>TGS-2024043856 v9.2 | Synthetic Lumina example | 2026-09-30 | All filters All | Slide2</a:t>
+              <a:t>TGS-2024043856 v9.3 | Synthetic Lumina example | 2026-09-30 | All filters All | Slide2</a:t>
             </a:r>
           </a:p>
         </p:txBody>
@@ -4327,7 +4327,7 @@
               <a:defRPr sz="1000"/>
             </a:pPr>
             <a:r>
-              <a:t>TGS-2024043856 v9.2 | Synthetic Lumina example | 2026-09-30 | All filters All | Slide3</a:t>
+              <a:t>TGS-2024043856 v9.3 | Synthetic Lumina example | 2026-09-30 | All filters All | Slide3</a:t>
             </a:r>
           </a:p>
         </p:txBody>
@@ -4442,7 +4442,7 @@
               <a:defRPr sz="1000"/>
             </a:pPr>
             <a:r>
-              <a:t>TGS-2024043856 v9.2 | Synthetic Lumina example | 2026-09-30 | All filters All | Slide4</a:t>
+              <a:t>TGS-2024043856 v9.3 | Synthetic Lumina example | 2026-09-30 | All filters All | Slide4</a:t>
             </a:r>
           </a:p>
         </p:txBody>
@@ -4557,7 +4557,7 @@
               <a:defRPr sz="1000"/>
             </a:pPr>
             <a:r>
-              <a:t>TGS-2024043856 v9.2 | Synthetic Lumina example | 2026-09-30 | All filters All | Slide5</a:t>
+              <a:t>TGS-2024043856 v9.3 | Synthetic Lumina example | 2026-09-30 | All filters All | Slide5</a:t>
             </a:r>
           </a:p>
         </p:txBody>
@@ -4672,7 +4672,7 @@
               <a:defRPr sz="1000"/>
             </a:pPr>
             <a:r>
-              <a:t>TGS-2024043856 v9.2 | Synthetic Lumina example | 2026-09-30 | All filters All | Slide6</a:t>
+              <a:t>TGS-2024043856 v9.3 | Synthetic Lumina example | 2026-09-30 | All filters All | Slide6</a:t>
             </a:r>
           </a:p>
         </p:txBody>
@@ -4787,7 +4787,7 @@
               <a:defRPr sz="1000"/>
             </a:pPr>
             <a:r>
-              <a:t>TGS-2024043856 v9.2 | Synthetic Lumina example | 2026-09-30 | All filters All | Slide7</a:t>
+              <a:t>TGS-2024043856 v9.3 | Synthetic Lumina example | 2026-09-30 | All filters All | Slide7</a:t>
             </a:r>
           </a:p>
         </p:txBody>
@@ -4902,7 +4902,7 @@
               <a:defRPr sz="1000"/>
             </a:pPr>
             <a:r>
-              <a:t>TGS-2024043856 v9.2 | Synthetic Lumina example | 2026-09-30 | All filters All | Slide8</a:t>
+              <a:t>TGS-2024043856 v9.3 | Synthetic Lumina example | 2026-09-30 | All filters All | Slide8</a:t>
             </a:r>
           </a:p>
         </p:txBody>

</xml_diff>

<commit_message>
docs: v9.4 adopts revised learning outcomes and topic titles
LO3: Evaluate opportunities in using Microsoft Copilot.
LO4: Design a training plan for staff to use Microsoft Copilot.
Topics: Overview of Microsoft Copilot; Microsoft Copilot for Excel;
Create Interactive Dashboard with Microsoft Copilot; Create Microsoft
Agent. Labs, timing and assessments unchanged.

Co-Authored-By: Claude Opus 5.5 <noreply@anthropic.com>
</commit_message>
<xml_diff>
--- a/labs/lab-01-excel-to-word/data/templates/Lumina_HR_Deck_Template.pptx
+++ b/labs/lab-01-excel-to-word/data/templates/Lumina_HR_Deck_Template.pptx
@@ -4097,7 +4097,7 @@
               <a:defRPr sz="1000"/>
             </a:pPr>
             <a:r>
-              <a:t>TGS-2024043856 v9.3 | Synthetic Lumina example | 2026-09-30 | All filters All | Slide1</a:t>
+              <a:t>TGS-2024043856 v9.4 | Synthetic Lumina example | 2026-09-30 | All filters All | Slide1</a:t>
             </a:r>
           </a:p>
         </p:txBody>
@@ -4212,7 +4212,7 @@
               <a:defRPr sz="1000"/>
             </a:pPr>
             <a:r>
-              <a:t>TGS-2024043856 v9.3 | Synthetic Lumina example | 2026-09-30 | All filters All | Slide2</a:t>
+              <a:t>TGS-2024043856 v9.4 | Synthetic Lumina example | 2026-09-30 | All filters All | Slide2</a:t>
             </a:r>
           </a:p>
         </p:txBody>
@@ -4327,7 +4327,7 @@
               <a:defRPr sz="1000"/>
             </a:pPr>
             <a:r>
-              <a:t>TGS-2024043856 v9.3 | Synthetic Lumina example | 2026-09-30 | All filters All | Slide3</a:t>
+              <a:t>TGS-2024043856 v9.4 | Synthetic Lumina example | 2026-09-30 | All filters All | Slide3</a:t>
             </a:r>
           </a:p>
         </p:txBody>
@@ -4442,7 +4442,7 @@
               <a:defRPr sz="1000"/>
             </a:pPr>
             <a:r>
-              <a:t>TGS-2024043856 v9.3 | Synthetic Lumina example | 2026-09-30 | All filters All | Slide4</a:t>
+              <a:t>TGS-2024043856 v9.4 | Synthetic Lumina example | 2026-09-30 | All filters All | Slide4</a:t>
             </a:r>
           </a:p>
         </p:txBody>
@@ -4557,7 +4557,7 @@
               <a:defRPr sz="1000"/>
             </a:pPr>
             <a:r>
-              <a:t>TGS-2024043856 v9.3 | Synthetic Lumina example | 2026-09-30 | All filters All | Slide5</a:t>
+              <a:t>TGS-2024043856 v9.4 | Synthetic Lumina example | 2026-09-30 | All filters All | Slide5</a:t>
             </a:r>
           </a:p>
         </p:txBody>
@@ -4672,7 +4672,7 @@
               <a:defRPr sz="1000"/>
             </a:pPr>
             <a:r>
-              <a:t>TGS-2024043856 v9.3 | Synthetic Lumina example | 2026-09-30 | All filters All | Slide6</a:t>
+              <a:t>TGS-2024043856 v9.4 | Synthetic Lumina example | 2026-09-30 | All filters All | Slide6</a:t>
             </a:r>
           </a:p>
         </p:txBody>
@@ -4787,7 +4787,7 @@
               <a:defRPr sz="1000"/>
             </a:pPr>
             <a:r>
-              <a:t>TGS-2024043856 v9.3 | Synthetic Lumina example | 2026-09-30 | All filters All | Slide7</a:t>
+              <a:t>TGS-2024043856 v9.4 | Synthetic Lumina example | 2026-09-30 | All filters All | Slide7</a:t>
             </a:r>
           </a:p>
         </p:txBody>
@@ -4902,7 +4902,7 @@
               <a:defRPr sz="1000"/>
             </a:pPr>
             <a:r>
-              <a:t>TGS-2024043856 v9.3 | Synthetic Lumina example | 2026-09-30 | All filters All | Slide8</a:t>
+              <a:t>TGS-2024043856 v9.4 | Synthetic Lumina example | 2026-09-30 | All filters All | Slide8</a:t>
             </a:r>
           </a:p>
         </p:txBody>

</xml_diff>

<commit_message>
feat: v9.5 adds the standard WSQ admin pages to the deck
Adds "Login to LMS and Download Course Material" (TMS sign-in screenshot)
after Ground Rules, Briefing for Assessment / Assessment & Funding /
Assessment Flow to the front admin block, and "Courseware & Assessment on
the LMS" before the end assessment block. Cover title and dark-slide
footers no longer overlap the decorative circles. LP, LG, labs and
prompt page re-issued as v9.5; v9.4 deck moved to the private archive.

Co-Authored-By: Claude Opus 5.5 <noreply@anthropic.com>
</commit_message>
<xml_diff>
--- a/labs/lab-01-excel-to-word/data/templates/Lumina_HR_Deck_Template.pptx
+++ b/labs/lab-01-excel-to-word/data/templates/Lumina_HR_Deck_Template.pptx
@@ -4097,7 +4097,7 @@
               <a:defRPr sz="1000"/>
             </a:pPr>
             <a:r>
-              <a:t>TGS-2024043856 v9.4 | Synthetic Lumina example | 2026-09-30 | All filters All | Slide1</a:t>
+              <a:t>TGS-2024043856 v9.5 | Synthetic Lumina example | 2026-09-30 | All filters All | Slide1</a:t>
             </a:r>
           </a:p>
         </p:txBody>
@@ -4212,7 +4212,7 @@
               <a:defRPr sz="1000"/>
             </a:pPr>
             <a:r>
-              <a:t>TGS-2024043856 v9.4 | Synthetic Lumina example | 2026-09-30 | All filters All | Slide2</a:t>
+              <a:t>TGS-2024043856 v9.5 | Synthetic Lumina example | 2026-09-30 | All filters All | Slide2</a:t>
             </a:r>
           </a:p>
         </p:txBody>
@@ -4327,7 +4327,7 @@
               <a:defRPr sz="1000"/>
             </a:pPr>
             <a:r>
-              <a:t>TGS-2024043856 v9.4 | Synthetic Lumina example | 2026-09-30 | All filters All | Slide3</a:t>
+              <a:t>TGS-2024043856 v9.5 | Synthetic Lumina example | 2026-09-30 | All filters All | Slide3</a:t>
             </a:r>
           </a:p>
         </p:txBody>
@@ -4442,7 +4442,7 @@
               <a:defRPr sz="1000"/>
             </a:pPr>
             <a:r>
-              <a:t>TGS-2024043856 v9.4 | Synthetic Lumina example | 2026-09-30 | All filters All | Slide4</a:t>
+              <a:t>TGS-2024043856 v9.5 | Synthetic Lumina example | 2026-09-30 | All filters All | Slide4</a:t>
             </a:r>
           </a:p>
         </p:txBody>
@@ -4557,7 +4557,7 @@
               <a:defRPr sz="1000"/>
             </a:pPr>
             <a:r>
-              <a:t>TGS-2024043856 v9.4 | Synthetic Lumina example | 2026-09-30 | All filters All | Slide5</a:t>
+              <a:t>TGS-2024043856 v9.5 | Synthetic Lumina example | 2026-09-30 | All filters All | Slide5</a:t>
             </a:r>
           </a:p>
         </p:txBody>
@@ -4672,7 +4672,7 @@
               <a:defRPr sz="1000"/>
             </a:pPr>
             <a:r>
-              <a:t>TGS-2024043856 v9.4 | Synthetic Lumina example | 2026-09-30 | All filters All | Slide6</a:t>
+              <a:t>TGS-2024043856 v9.5 | Synthetic Lumina example | 2026-09-30 | All filters All | Slide6</a:t>
             </a:r>
           </a:p>
         </p:txBody>
@@ -4787,7 +4787,7 @@
               <a:defRPr sz="1000"/>
             </a:pPr>
             <a:r>
-              <a:t>TGS-2024043856 v9.4 | Synthetic Lumina example | 2026-09-30 | All filters All | Slide7</a:t>
+              <a:t>TGS-2024043856 v9.5 | Synthetic Lumina example | 2026-09-30 | All filters All | Slide7</a:t>
             </a:r>
           </a:p>
         </p:txBody>
@@ -4902,7 +4902,7 @@
               <a:defRPr sz="1000"/>
             </a:pPr>
             <a:r>
-              <a:t>TGS-2024043856 v9.4 | Synthetic Lumina example | 2026-09-30 | All filters All | Slide8</a:t>
+              <a:t>TGS-2024043856 v9.5 | Synthetic Lumina example | 2026-09-30 | All filters All | Slide8</a:t>
             </a:r>
           </a:p>
         </p:txBody>

</xml_diff>